<commit_message>
Fix : traduction des cells de tableau PPTX (slide 4 manquante)
Bug signale par Jacques : la slide 4 (tableau des garanties) restait en
francais dans le .pptx EN. Cause :

1. parse_pptx ne walkait pas les cells de tables (juste capturait le
   table_df separement, sans span_id par cell)
2. build_pptx_document ne walkait pas non plus les cell.text_frame

Fix :
- parse_pptx : ajout du walk cells/text_frame/paragraph/runs avec span_id
  format pp_<slide>_<shape>_t_<row>_<col>_<para>_<run>. Nouvelles colonnes
  in_table / table_row / table_col dans runs_df.
- build_pptx_document : factorise _apply_to_text_frame, walk a la fois les
  shape.text_frame ET les shape.table.cells.text_frame.
- Notebook : dict FR->EN enrichi avec les 12 cells de tableau (Garantie,
  Plafond, Franchise + 9 valeurs).

Resultat : 28 runs au total dont 12 dans la table, tous traduits dans
notebooks/_outputs/pptx_translation/contrat_assurance_EN_js.pptx,
verifie au re-parse.
</commit_message>
<xml_diff>
--- a/notebooks/_outputs/pptx_translation/contrat_assurance_EN_js.pptx
+++ b/notebooks/_outputs/pptx_translation/contrat_assurance_EN_js.pptx
@@ -3800,7 +3800,7 @@
                     <a:lstStyle/>
                     <a:p>
                       <a:r>
-                        <a:t>Garantie</a:t>
+                        <a:t>Coverage</a:t>
                       </a:r>
                     </a:p>
                   </a:txBody>
@@ -3812,7 +3812,7 @@
                     <a:lstStyle/>
                     <a:p>
                       <a:r>
-                        <a:t>Plafond</a:t>
+                        <a:t>Limit</a:t>
                       </a:r>
                     </a:p>
                   </a:txBody>
@@ -3824,7 +3824,7 @@
                     <a:lstStyle/>
                     <a:p>
                       <a:r>
-                        <a:t>Franchise</a:t>
+                        <a:t>Deductible</a:t>
                       </a:r>
                     </a:p>
                   </a:txBody>
@@ -3850,7 +3850,7 @@
                     <a:lstStyle/>
                     <a:p>
                       <a:r>
-                        <a:t>50 000 EUR</a:t>
+                        <a:t>50,000 EUR</a:t>
                       </a:r>
                     </a:p>
                   </a:txBody>
@@ -3888,7 +3888,7 @@
                     <a:lstStyle/>
                     <a:p>
                       <a:r>
-                        <a:t>100 000 EUR</a:t>
+                        <a:t>100,000 EUR</a:t>
                       </a:r>
                     </a:p>
                   </a:txBody>
@@ -3900,7 +3900,7 @@
                     <a:lstStyle/>
                     <a:p>
                       <a:r>
-                        <a:t>1 000 EUR</a:t>
+                        <a:t>1,000 EUR</a:t>
                       </a:r>
                     </a:p>
                   </a:txBody>
@@ -3914,7 +3914,7 @@
                     <a:lstStyle/>
                     <a:p>
                       <a:r>
-                        <a:t>RC — Responsabilité Civile</a:t>
+                        <a:t>RC — Civil Liability</a:t>
                       </a:r>
                     </a:p>
                   </a:txBody>
@@ -3926,7 +3926,7 @@
                     <a:lstStyle/>
                     <a:p>
                       <a:r>
-                        <a:t>200 000 EUR</a:t>
+                        <a:t>200,000 EUR</a:t>
                       </a:r>
                     </a:p>
                   </a:txBody>

</xml_diff>